<commit_message>
Slide 4 becomes a per-cohort panel with seed error bars; disambiguate k on slide 6
Slide 4 was a single table of means over six targets, which hides that the
classical-vs-SSL gap is not uniform: +0.051 on BrC-T2D 4-class, +0.101 on Barth.
Replaced with one panel per cohort.

Error bars are the sd ACROSS PRETRAINING SEEDS, not across episodes. Episode
spread is shared by every representation because the episodes are paired, so it
says nothing about which representation is better. Seed spread says how much of a
reported gap is just which checkpoint you picked -- the selection error this
project has retracted twice.

Slide 6 used k for the label budget while the row labels used k for study count.
Column headers now read "10 labels/class" and "all labels".

Also adds phase4_rebalance.sh: yttrium was running its 11-job shard serially
while matlab1 and matlab2 sat idle. It reuses the queue's .done guard, so it
cannot duplicate work.

Co-Authored-By: Claude Opus 5 <noreply@anthropic.com>
</commit_message>
<xml_diff>
--- a/docs/Weekly_Update_2026-09-18.pptx
+++ b/docs/Weekly_Update_2026-09-18.pptx
@@ -9,8 +9,8 @@
     <p:sldId id="257" r:id="rId8"/>
     <p:sldId id="258" r:id="rId9"/>
     <p:sldId id="259" r:id="rId10"/>
-    <p:sldId id="260" r:id="rId11"/>
-    <p:sldId id="261" r:id="rId12"/>
+    <p:sldId id="260" r:id="rId12"/>
+    <p:sldId id="261" r:id="rId13"/>
   </p:sldIdLst>
   <p:sldSz cx="12191695" cy="6858000" type="screen4x3"/>
   <p:notesSz cx="6858000" cy="9144000"/>
@@ -110,6 +110,426 @@
     </a:lvl9pPr>
   </p:defaultTextStyle>
 </p:presentation>
+</file>
+
+<file path=ppt/notesMasters/notesMaster1.xml><?xml version="1.0" encoding="utf-8"?>
+<p:notesMaster xmlns:a="http://schemas.openxmlformats.org/drawingml/2006/main" xmlns:p="http://schemas.openxmlformats.org/presentationml/2006/main" xmlns:r="http://schemas.openxmlformats.org/officeDocument/2006/relationships">
+  <p:cSld>
+    <p:bg>
+      <p:bgRef idx="1001">
+        <a:schemeClr val="bg1"/>
+      </p:bgRef>
+    </p:bg>
+    <p:spTree>
+      <p:nvGrpSpPr>
+        <p:cNvPr id="1" name=""/>
+        <p:cNvGrpSpPr/>
+        <p:nvPr/>
+      </p:nvGrpSpPr>
+      <p:grpSpPr>
+        <a:xfrm>
+          <a:off x="0" y="0"/>
+          <a:ext cx="0" cy="0"/>
+          <a:chOff x="0" y="0"/>
+          <a:chExt cx="0" cy="0"/>
+        </a:xfrm>
+      </p:grpSpPr>
+      <p:sp>
+        <p:nvSpPr>
+          <p:cNvPr id="2" name="Header Placeholder 1"/>
+          <p:cNvSpPr>
+            <a:spLocks noGrp="1"/>
+          </p:cNvSpPr>
+          <p:nvPr>
+            <p:ph type="hdr" sz="quarter"/>
+          </p:nvPr>
+        </p:nvSpPr>
+        <p:spPr>
+          <a:xfrm>
+            <a:off x="0" y="0"/>
+            <a:ext cx="2971800" cy="457200"/>
+          </a:xfrm>
+          <a:prstGeom prst="rect">
+            <a:avLst/>
+          </a:prstGeom>
+        </p:spPr>
+        <p:txBody>
+          <a:bodyPr vert="horz" lIns="91440" tIns="45720" rIns="91440" bIns="45720" rtlCol="0"/>
+          <a:lstStyle>
+            <a:lvl1pPr algn="l">
+              <a:defRPr sz="1200"/>
+            </a:lvl1pPr>
+          </a:lstStyle>
+          <a:p>
+            <a:endParaRPr lang="en-US"/>
+          </a:p>
+        </p:txBody>
+      </p:sp>
+      <p:sp>
+        <p:nvSpPr>
+          <p:cNvPr id="3" name="Date Placeholder 2"/>
+          <p:cNvSpPr>
+            <a:spLocks noGrp="1"/>
+          </p:cNvSpPr>
+          <p:nvPr>
+            <p:ph type="dt" idx="1"/>
+          </p:nvPr>
+        </p:nvSpPr>
+        <p:spPr>
+          <a:xfrm>
+            <a:off x="3884613" y="0"/>
+            <a:ext cx="2971800" cy="457200"/>
+          </a:xfrm>
+          <a:prstGeom prst="rect">
+            <a:avLst/>
+          </a:prstGeom>
+        </p:spPr>
+        <p:txBody>
+          <a:bodyPr vert="horz" lIns="91440" tIns="45720" rIns="91440" bIns="45720" rtlCol="0"/>
+          <a:lstStyle>
+            <a:lvl1pPr algn="r">
+              <a:defRPr sz="1200"/>
+            </a:lvl1pPr>
+          </a:lstStyle>
+          <a:p>
+            <a:fld id="{0F89C1C7-3DCD-1040-A9CF-14679D8B5DDD}" type="datetimeFigureOut">
+              <a:rPr lang="en-US" smtClean="0"/>
+              <a:t>10/17/16</a:t>
+            </a:fld>
+            <a:endParaRPr lang="en-US"/>
+          </a:p>
+        </p:txBody>
+      </p:sp>
+      <p:sp>
+        <p:nvSpPr>
+          <p:cNvPr id="4" name="Slide Image Placeholder 3"/>
+          <p:cNvSpPr>
+            <a:spLocks noGrp="1" noRot="1" noChangeAspect="1"/>
+          </p:cNvSpPr>
+          <p:nvPr>
+            <p:ph type="sldImg" idx="2"/>
+          </p:nvPr>
+        </p:nvSpPr>
+        <p:spPr>
+          <a:xfrm>
+            <a:off x="1143000" y="685800"/>
+            <a:ext cx="4572000" cy="3429000"/>
+          </a:xfrm>
+          <a:prstGeom prst="rect">
+            <a:avLst/>
+          </a:prstGeom>
+          <a:noFill/>
+          <a:ln w="12700">
+            <a:solidFill>
+              <a:prstClr val="black"/>
+            </a:solidFill>
+          </a:ln>
+        </p:spPr>
+        <p:txBody>
+          <a:bodyPr vert="horz" lIns="91440" tIns="45720" rIns="91440" bIns="45720" rtlCol="0" anchor="ctr"/>
+          <a:lstStyle/>
+          <a:p>
+            <a:endParaRPr lang="en-US"/>
+          </a:p>
+        </p:txBody>
+      </p:sp>
+      <p:sp>
+        <p:nvSpPr>
+          <p:cNvPr id="5" name="Notes Placeholder 4"/>
+          <p:cNvSpPr>
+            <a:spLocks noGrp="1"/>
+          </p:cNvSpPr>
+          <p:nvPr>
+            <p:ph type="body" sz="quarter" idx="3"/>
+          </p:nvPr>
+        </p:nvSpPr>
+        <p:spPr>
+          <a:xfrm>
+            <a:off x="685800" y="4343400"/>
+            <a:ext cx="5486400" cy="4114800"/>
+          </a:xfrm>
+          <a:prstGeom prst="rect">
+            <a:avLst/>
+          </a:prstGeom>
+        </p:spPr>
+        <p:txBody>
+          <a:bodyPr vert="horz" lIns="91440" tIns="45720" rIns="91440" bIns="45720" rtlCol="0"/>
+          <a:lstStyle/>
+          <a:p>
+            <a:pPr lvl="0"/>
+            <a:r>
+              <a:rPr lang="en-US" smtClean="0"/>
+              <a:t>Click to edit Master text styles</a:t>
+            </a:r>
+          </a:p>
+          <a:p>
+            <a:pPr lvl="1"/>
+            <a:r>
+              <a:rPr lang="en-US" smtClean="0"/>
+              <a:t>Second level</a:t>
+            </a:r>
+          </a:p>
+          <a:p>
+            <a:pPr lvl="2"/>
+            <a:r>
+              <a:rPr lang="en-US" smtClean="0"/>
+              <a:t>Third level</a:t>
+            </a:r>
+          </a:p>
+          <a:p>
+            <a:pPr lvl="3"/>
+            <a:r>
+              <a:rPr lang="en-US" smtClean="0"/>
+              <a:t>Fourth level</a:t>
+            </a:r>
+          </a:p>
+          <a:p>
+            <a:pPr lvl="4"/>
+            <a:r>
+              <a:rPr lang="en-US" smtClean="0"/>
+              <a:t>Fifth level</a:t>
+            </a:r>
+            <a:endParaRPr lang="en-US"/>
+          </a:p>
+        </p:txBody>
+      </p:sp>
+      <p:sp>
+        <p:nvSpPr>
+          <p:cNvPr id="6" name="Footer Placeholder 5"/>
+          <p:cNvSpPr>
+            <a:spLocks noGrp="1"/>
+          </p:cNvSpPr>
+          <p:nvPr>
+            <p:ph type="ftr" sz="quarter" idx="4"/>
+          </p:nvPr>
+        </p:nvSpPr>
+        <p:spPr>
+          <a:xfrm>
+            <a:off x="0" y="8685213"/>
+            <a:ext cx="2971800" cy="457200"/>
+          </a:xfrm>
+          <a:prstGeom prst="rect">
+            <a:avLst/>
+          </a:prstGeom>
+        </p:spPr>
+        <p:txBody>
+          <a:bodyPr vert="horz" lIns="91440" tIns="45720" rIns="91440" bIns="45720" rtlCol="0" anchor="b"/>
+          <a:lstStyle>
+            <a:lvl1pPr algn="l">
+              <a:defRPr sz="1200"/>
+            </a:lvl1pPr>
+          </a:lstStyle>
+          <a:p>
+            <a:endParaRPr lang="en-US"/>
+          </a:p>
+        </p:txBody>
+      </p:sp>
+      <p:sp>
+        <p:nvSpPr>
+          <p:cNvPr id="7" name="Slide Number Placeholder 6"/>
+          <p:cNvSpPr>
+            <a:spLocks noGrp="1"/>
+          </p:cNvSpPr>
+          <p:nvPr>
+            <p:ph type="sldNum" sz="quarter" idx="5"/>
+          </p:nvPr>
+        </p:nvSpPr>
+        <p:spPr>
+          <a:xfrm>
+            <a:off x="3884613" y="8685213"/>
+            <a:ext cx="2971800" cy="457200"/>
+          </a:xfrm>
+          <a:prstGeom prst="rect">
+            <a:avLst/>
+          </a:prstGeom>
+        </p:spPr>
+        <p:txBody>
+          <a:bodyPr vert="horz" lIns="91440" tIns="45720" rIns="91440" bIns="45720" rtlCol="0" anchor="b"/>
+          <a:lstStyle>
+            <a:lvl1pPr algn="r">
+              <a:defRPr sz="1200"/>
+            </a:lvl1pPr>
+          </a:lstStyle>
+          <a:p>
+            <a:fld id="{BB5E49A5-4136-284D-997B-48E1D791AD67}" type="slidenum">
+              <a:rPr lang="en-US" smtClean="0"/>
+              <a:t>‹#›</a:t>
+            </a:fld>
+            <a:endParaRPr lang="en-US"/>
+          </a:p>
+        </p:txBody>
+      </p:sp>
+    </p:spTree>
+    <p:extLst>
+      <p:ext uri="{BB962C8B-B14F-4D97-AF65-F5344CB8AC3E}">
+        <p14:creationId xmlns:p14="http://schemas.microsoft.com/office/powerpoint/2010/main" val="2623252185"/>
+      </p:ext>
+    </p:extLst>
+  </p:cSld>
+  <p:clrMap bg1="lt1" tx1="dk1" bg2="lt2" tx2="dk2" accent1="accent1" accent2="accent2" accent3="accent3" accent4="accent4" accent5="accent5" accent6="accent6" hlink="hlink" folHlink="folHlink"/>
+  <p:notesStyle>
+    <a:lvl1pPr marL="0" algn="l" defTabSz="457200" rtl="0" eaLnBrk="1" latinLnBrk="0" hangingPunct="1">
+      <a:defRPr sz="1200" kern="1200">
+        <a:solidFill>
+          <a:schemeClr val="tx1"/>
+        </a:solidFill>
+        <a:latin typeface="+mn-lt"/>
+        <a:ea typeface="+mn-ea"/>
+        <a:cs typeface="+mn-cs"/>
+      </a:defRPr>
+    </a:lvl1pPr>
+    <a:lvl2pPr marL="457200" algn="l" defTabSz="457200" rtl="0" eaLnBrk="1" latinLnBrk="0" hangingPunct="1">
+      <a:defRPr sz="1200" kern="1200">
+        <a:solidFill>
+          <a:schemeClr val="tx1"/>
+        </a:solidFill>
+        <a:latin typeface="+mn-lt"/>
+        <a:ea typeface="+mn-ea"/>
+        <a:cs typeface="+mn-cs"/>
+      </a:defRPr>
+    </a:lvl2pPr>
+    <a:lvl3pPr marL="914400" algn="l" defTabSz="457200" rtl="0" eaLnBrk="1" latinLnBrk="0" hangingPunct="1">
+      <a:defRPr sz="1200" kern="1200">
+        <a:solidFill>
+          <a:schemeClr val="tx1"/>
+        </a:solidFill>
+        <a:latin typeface="+mn-lt"/>
+        <a:ea typeface="+mn-ea"/>
+        <a:cs typeface="+mn-cs"/>
+      </a:defRPr>
+    </a:lvl3pPr>
+    <a:lvl4pPr marL="1371600" algn="l" defTabSz="457200" rtl="0" eaLnBrk="1" latinLnBrk="0" hangingPunct="1">
+      <a:defRPr sz="1200" kern="1200">
+        <a:solidFill>
+          <a:schemeClr val="tx1"/>
+        </a:solidFill>
+        <a:latin typeface="+mn-lt"/>
+        <a:ea typeface="+mn-ea"/>
+        <a:cs typeface="+mn-cs"/>
+      </a:defRPr>
+    </a:lvl4pPr>
+    <a:lvl5pPr marL="1828800" algn="l" defTabSz="457200" rtl="0" eaLnBrk="1" latinLnBrk="0" hangingPunct="1">
+      <a:defRPr sz="1200" kern="1200">
+        <a:solidFill>
+          <a:schemeClr val="tx1"/>
+        </a:solidFill>
+        <a:latin typeface="+mn-lt"/>
+        <a:ea typeface="+mn-ea"/>
+        <a:cs typeface="+mn-cs"/>
+      </a:defRPr>
+    </a:lvl5pPr>
+    <a:lvl6pPr marL="2286000" algn="l" defTabSz="457200" rtl="0" eaLnBrk="1" latinLnBrk="0" hangingPunct="1">
+      <a:defRPr sz="1200" kern="1200">
+        <a:solidFill>
+          <a:schemeClr val="tx1"/>
+        </a:solidFill>
+        <a:latin typeface="+mn-lt"/>
+        <a:ea typeface="+mn-ea"/>
+        <a:cs typeface="+mn-cs"/>
+      </a:defRPr>
+    </a:lvl6pPr>
+    <a:lvl7pPr marL="2743200" algn="l" defTabSz="457200" rtl="0" eaLnBrk="1" latinLnBrk="0" hangingPunct="1">
+      <a:defRPr sz="1200" kern="1200">
+        <a:solidFill>
+          <a:schemeClr val="tx1"/>
+        </a:solidFill>
+        <a:latin typeface="+mn-lt"/>
+        <a:ea typeface="+mn-ea"/>
+        <a:cs typeface="+mn-cs"/>
+      </a:defRPr>
+    </a:lvl7pPr>
+    <a:lvl8pPr marL="3200400" algn="l" defTabSz="457200" rtl="0" eaLnBrk="1" latinLnBrk="0" hangingPunct="1">
+      <a:defRPr sz="1200" kern="1200">
+        <a:solidFill>
+          <a:schemeClr val="tx1"/>
+        </a:solidFill>
+        <a:latin typeface="+mn-lt"/>
+        <a:ea typeface="+mn-ea"/>
+        <a:cs typeface="+mn-cs"/>
+      </a:defRPr>
+    </a:lvl8pPr>
+    <a:lvl9pPr marL="3657600" algn="l" defTabSz="457200" rtl="0" eaLnBrk="1" latinLnBrk="0" hangingPunct="1">
+      <a:defRPr sz="1200" kern="1200">
+        <a:solidFill>
+          <a:schemeClr val="tx1"/>
+        </a:solidFill>
+        <a:latin typeface="+mn-lt"/>
+        <a:ea typeface="+mn-ea"/>
+        <a:cs typeface="+mn-cs"/>
+      </a:defRPr>
+    </a:lvl9pPr>
+  </p:notesStyle>
+</p:notesMaster>
+</file>
+
+<file path=ppt/notesSlides/notesSlide1.xml><?xml version="1.0" encoding="utf-8"?>
+<p:notes xmlns:a="http://schemas.openxmlformats.org/drawingml/2006/main" xmlns:p="http://schemas.openxmlformats.org/presentationml/2006/main" xmlns:r="http://schemas.openxmlformats.org/officeDocument/2006/relationships">
+  <p:cSld>
+    <p:spTree>
+      <p:nvGrpSpPr>
+        <p:cNvPr id="1" name=""/>
+        <p:cNvGrpSpPr/>
+        <p:nvPr/>
+      </p:nvGrpSpPr>
+      <p:grpSpPr>
+        <a:xfrm>
+          <a:off x="0" y="0"/>
+          <a:ext cx="0" cy="0"/>
+          <a:chOff x="0" y="0"/>
+          <a:chExt cx="0" cy="0"/>
+        </a:xfrm>
+      </p:grpSpPr>
+      <p:sp>
+        <p:nvSpPr>
+          <p:cNvPr id="2" name="Slide Image Placeholder 1"/>
+          <p:cNvSpPr>
+            <a:spLocks noGrp="1"/>
+          </p:cNvSpPr>
+          <p:nvPr>
+            <p:ph type="sldImg" idx="2"/>
+          </p:nvPr>
+        </p:nvSpPr>
+        <p:spPr/>
+      </p:sp>
+      <p:sp>
+        <p:nvSpPr>
+          <p:cNvPr id="3" name="Notes Placeholder 2"/>
+          <p:cNvSpPr>
+            <a:spLocks noGrp="1"/>
+          </p:cNvSpPr>
+          <p:nvPr>
+            <p:ph type="body" idx="3" sz="quarter"/>
+          </p:nvPr>
+        </p:nvSpPr>
+        <p:spPr/>
+        <p:txBody>
+          <a:bodyPr/>
+          <a:lstStyle/>
+          <a:p>
+            <a:r>
+              <a:t>Two claims withdrawn this week. (1) Effective rank does not predict transfer - I predicted joint would win on that basis, and masking won at every budget. (2) An apparent Barth win was selection bias from reporting the best of 15 checkpoints; every objective seed mean is below classical. The summary now reports seed means and marks best-of-15 as an upper bound.</a:t>
+            </a:r>
+          </a:p>
+        </p:txBody>
+      </p:sp>
+      <p:sp>
+        <p:nvSpPr>
+          <p:cNvPr id="4" name="Slide Number Placeholder 3"/>
+          <p:cNvSpPr>
+            <a:spLocks noGrp="1"/>
+          </p:cNvSpPr>
+          <p:nvPr>
+            <p:ph type="sldNum" idx="5" sz="quarter"/>
+          </p:nvPr>
+        </p:nvSpPr>
+        <p:spPr/>
+      </p:sp>
+    </p:spTree>
+  </p:cSld>
+  <p:clrMapOvr>
+    <a:masterClrMapping/>
+  </p:clrMapOvr>
+</p:notes>
 </file>
 
 <file path=ppt/slideLayouts/slideLayout1.xml><?xml version="1.0" encoding="utf-8"?>
@@ -4614,737 +5034,30 @@
           </a:p>
         </p:txBody>
       </p:sp>
-      <p:graphicFrame>
-        <p:nvGraphicFramePr>
-          <p:cNvPr id="5" name="Table 4"/>
-          <p:cNvGraphicFramePr>
-            <a:graphicFrameLocks noGrp="1"/>
-          </p:cNvGraphicFramePr>
+      <p:pic>
+        <p:nvPicPr>
+          <p:cNvPr id="5" name="Picture 4" descr="fig7_G1_per_cohort_slim.png"/>
+          <p:cNvPicPr>
+            <a:picLocks noChangeAspect="1"/>
+          </p:cNvPicPr>
           <p:nvPr/>
-        </p:nvGraphicFramePr>
-        <p:xfrm>
-          <a:off x="502920" y="1463040"/>
-          <a:ext cx="5577840" cy="1920240"/>
-        </p:xfrm>
-        <a:graphic>
-          <a:graphicData uri="http://schemas.openxmlformats.org/drawingml/2006/table">
-            <a:tbl>
-              <a:tblPr firstRow="1" bandRow="1">
-                <a:tableStyleId>{5C22544A-7EE6-4342-B048-85BDC9FD1C3A}</a:tableStyleId>
-              </a:tblPr>
-              <a:tblGrid>
-                <a:gridCol w="1234440"/>
-                <a:gridCol w="1143000"/>
-                <a:gridCol w="1143000"/>
-                <a:gridCol w="1051560"/>
-                <a:gridCol w="1005840"/>
-              </a:tblGrid>
-              <a:tr h="320040">
-                <a:tc>
-                  <a:txBody>
-                    <a:bodyPr/>
-                    <a:lstStyle/>
-                    <a:p>
-                      <a:pPr algn="ctr"/>
-                      <a:r>
-                        <a:rPr sz="1150" b="1">
-                          <a:solidFill>
-                            <a:srgbClr val="1E2761"/>
-                          </a:solidFill>
-                          <a:latin typeface="Arial"/>
-                        </a:rPr>
-                        <a:t>k per class</a:t>
-                      </a:r>
-                    </a:p>
-                  </a:txBody>
-                  <a:tcPr anchor="ctr">
-                    <a:solidFill>
-                      <a:srgbClr val="F4F2EA"/>
-                    </a:solidFill>
-                  </a:tcPr>
-                </a:tc>
-                <a:tc>
-                  <a:txBody>
-                    <a:bodyPr/>
-                    <a:lstStyle/>
-                    <a:p>
-                      <a:pPr algn="ctr"/>
-                      <a:r>
-                        <a:rPr sz="1150" b="1">
-                          <a:solidFill>
-                            <a:srgbClr val="1E2761"/>
-                          </a:solidFill>
-                          <a:latin typeface="Arial"/>
-                        </a:rPr>
-                        <a:t>classical</a:t>
-                      </a:r>
-                    </a:p>
-                  </a:txBody>
-                  <a:tcPr anchor="ctr">
-                    <a:solidFill>
-                      <a:srgbClr val="F4F2EA"/>
-                    </a:solidFill>
-                  </a:tcPr>
-                </a:tc>
-                <a:tc>
-                  <a:txBody>
-                    <a:bodyPr/>
-                    <a:lstStyle/>
-                    <a:p>
-                      <a:pPr algn="ctr"/>
-                      <a:r>
-                        <a:rPr sz="1150" b="1">
-                          <a:solidFill>
-                            <a:srgbClr val="1E2761"/>
-                          </a:solidFill>
-                          <a:latin typeface="Arial"/>
-                        </a:rPr>
-                        <a:t>masking</a:t>
-                      </a:r>
-                    </a:p>
-                  </a:txBody>
-                  <a:tcPr anchor="ctr">
-                    <a:solidFill>
-                      <a:srgbClr val="F4F2EA"/>
-                    </a:solidFill>
-                  </a:tcPr>
-                </a:tc>
-                <a:tc>
-                  <a:txBody>
-                    <a:bodyPr/>
-                    <a:lstStyle/>
-                    <a:p>
-                      <a:pPr algn="ctr"/>
-                      <a:r>
-                        <a:rPr sz="1150" b="1">
-                          <a:solidFill>
-                            <a:srgbClr val="1E2761"/>
-                          </a:solidFill>
-                          <a:latin typeface="Arial"/>
-                        </a:rPr>
-                        <a:t>jigsaw</a:t>
-                      </a:r>
-                    </a:p>
-                  </a:txBody>
-                  <a:tcPr anchor="ctr">
-                    <a:solidFill>
-                      <a:srgbClr val="F4F2EA"/>
-                    </a:solidFill>
-                  </a:tcPr>
-                </a:tc>
-                <a:tc>
-                  <a:txBody>
-                    <a:bodyPr/>
-                    <a:lstStyle/>
-                    <a:p>
-                      <a:pPr algn="ctr"/>
-                      <a:r>
-                        <a:rPr sz="1150" b="1">
-                          <a:solidFill>
-                            <a:srgbClr val="1E2761"/>
-                          </a:solidFill>
-                          <a:latin typeface="Arial"/>
-                        </a:rPr>
-                        <a:t>joint</a:t>
-                      </a:r>
-                    </a:p>
-                  </a:txBody>
-                  <a:tcPr anchor="ctr">
-                    <a:solidFill>
-                      <a:srgbClr val="F4F2EA"/>
-                    </a:solidFill>
-                  </a:tcPr>
-                </a:tc>
-              </a:tr>
-              <a:tr h="320040">
-                <a:tc>
-                  <a:txBody>
-                    <a:bodyPr/>
-                    <a:lstStyle/>
-                    <a:p>
-                      <a:pPr algn="ctr"/>
-                      <a:r>
-                        <a:rPr sz="1150" b="0">
-                          <a:solidFill>
-                            <a:srgbClr val="3C3C48"/>
-                          </a:solidFill>
-                          <a:latin typeface="Arial"/>
-                        </a:rPr>
-                        <a:t>5</a:t>
-                      </a:r>
-                    </a:p>
-                  </a:txBody>
-                  <a:tcPr anchor="ctr">
-                    <a:solidFill>
-                      <a:srgbClr val="FFFFFF"/>
-                    </a:solidFill>
-                  </a:tcPr>
-                </a:tc>
-                <a:tc>
-                  <a:txBody>
-                    <a:bodyPr/>
-                    <a:lstStyle/>
-                    <a:p>
-                      <a:pPr algn="ctr"/>
-                      <a:r>
-                        <a:rPr sz="1150" b="0">
-                          <a:solidFill>
-                            <a:srgbClr val="2E5E9E"/>
-                          </a:solidFill>
-                          <a:latin typeface="Arial"/>
-                        </a:rPr>
-                        <a:t>0.597</a:t>
-                      </a:r>
-                    </a:p>
-                  </a:txBody>
-                  <a:tcPr anchor="ctr">
-                    <a:solidFill>
-                      <a:srgbClr val="FFFFFF"/>
-                    </a:solidFill>
-                  </a:tcPr>
-                </a:tc>
-                <a:tc>
-                  <a:txBody>
-                    <a:bodyPr/>
-                    <a:lstStyle/>
-                    <a:p>
-                      <a:pPr algn="ctr"/>
-                      <a:r>
-                        <a:rPr sz="1150" b="0">
-                          <a:solidFill>
-                            <a:srgbClr val="3C3C48"/>
-                          </a:solidFill>
-                          <a:latin typeface="Arial"/>
-                        </a:rPr>
-                        <a:t>0.549</a:t>
-                      </a:r>
-                    </a:p>
-                  </a:txBody>
-                  <a:tcPr anchor="ctr">
-                    <a:solidFill>
-                      <a:srgbClr val="FFFFFF"/>
-                    </a:solidFill>
-                  </a:tcPr>
-                </a:tc>
-                <a:tc>
-                  <a:txBody>
-                    <a:bodyPr/>
-                    <a:lstStyle/>
-                    <a:p>
-                      <a:pPr algn="ctr"/>
-                      <a:r>
-                        <a:rPr sz="1150" b="0">
-                          <a:solidFill>
-                            <a:srgbClr val="3C3C48"/>
-                          </a:solidFill>
-                          <a:latin typeface="Arial"/>
-                        </a:rPr>
-                        <a:t>0.498</a:t>
-                      </a:r>
-                    </a:p>
-                  </a:txBody>
-                  <a:tcPr anchor="ctr">
-                    <a:solidFill>
-                      <a:srgbClr val="FFFFFF"/>
-                    </a:solidFill>
-                  </a:tcPr>
-                </a:tc>
-                <a:tc>
-                  <a:txBody>
-                    <a:bodyPr/>
-                    <a:lstStyle/>
-                    <a:p>
-                      <a:pPr algn="ctr"/>
-                      <a:r>
-                        <a:rPr sz="1150" b="0">
-                          <a:solidFill>
-                            <a:srgbClr val="3C3C48"/>
-                          </a:solidFill>
-                          <a:latin typeface="Arial"/>
-                        </a:rPr>
-                        <a:t>0.516</a:t>
-                      </a:r>
-                    </a:p>
-                  </a:txBody>
-                  <a:tcPr anchor="ctr">
-                    <a:solidFill>
-                      <a:srgbClr val="FFFFFF"/>
-                    </a:solidFill>
-                  </a:tcPr>
-                </a:tc>
-              </a:tr>
-              <a:tr h="320040">
-                <a:tc>
-                  <a:txBody>
-                    <a:bodyPr/>
-                    <a:lstStyle/>
-                    <a:p>
-                      <a:pPr algn="ctr"/>
-                      <a:r>
-                        <a:rPr sz="1150" b="0">
-                          <a:solidFill>
-                            <a:srgbClr val="3C3C48"/>
-                          </a:solidFill>
-                          <a:latin typeface="Arial"/>
-                        </a:rPr>
-                        <a:t>10</a:t>
-                      </a:r>
-                    </a:p>
-                  </a:txBody>
-                  <a:tcPr anchor="ctr">
-                    <a:solidFill>
-                      <a:srgbClr val="FFFFFF"/>
-                    </a:solidFill>
-                  </a:tcPr>
-                </a:tc>
-                <a:tc>
-                  <a:txBody>
-                    <a:bodyPr/>
-                    <a:lstStyle/>
-                    <a:p>
-                      <a:pPr algn="ctr"/>
-                      <a:r>
-                        <a:rPr sz="1150" b="0">
-                          <a:solidFill>
-                            <a:srgbClr val="2E5E9E"/>
-                          </a:solidFill>
-                          <a:latin typeface="Arial"/>
-                        </a:rPr>
-                        <a:t>0.653</a:t>
-                      </a:r>
-                    </a:p>
-                  </a:txBody>
-                  <a:tcPr anchor="ctr">
-                    <a:solidFill>
-                      <a:srgbClr val="FFFFFF"/>
-                    </a:solidFill>
-                  </a:tcPr>
-                </a:tc>
-                <a:tc>
-                  <a:txBody>
-                    <a:bodyPr/>
-                    <a:lstStyle/>
-                    <a:p>
-                      <a:pPr algn="ctr"/>
-                      <a:r>
-                        <a:rPr sz="1150" b="0">
-                          <a:solidFill>
-                            <a:srgbClr val="3C3C48"/>
-                          </a:solidFill>
-                          <a:latin typeface="Arial"/>
-                        </a:rPr>
-                        <a:t>0.593</a:t>
-                      </a:r>
-                    </a:p>
-                  </a:txBody>
-                  <a:tcPr anchor="ctr">
-                    <a:solidFill>
-                      <a:srgbClr val="FFFFFF"/>
-                    </a:solidFill>
-                  </a:tcPr>
-                </a:tc>
-                <a:tc>
-                  <a:txBody>
-                    <a:bodyPr/>
-                    <a:lstStyle/>
-                    <a:p>
-                      <a:pPr algn="ctr"/>
-                      <a:r>
-                        <a:rPr sz="1150" b="0">
-                          <a:solidFill>
-                            <a:srgbClr val="3C3C48"/>
-                          </a:solidFill>
-                          <a:latin typeface="Arial"/>
-                        </a:rPr>
-                        <a:t>0.531</a:t>
-                      </a:r>
-                    </a:p>
-                  </a:txBody>
-                  <a:tcPr anchor="ctr">
-                    <a:solidFill>
-                      <a:srgbClr val="FFFFFF"/>
-                    </a:solidFill>
-                  </a:tcPr>
-                </a:tc>
-                <a:tc>
-                  <a:txBody>
-                    <a:bodyPr/>
-                    <a:lstStyle/>
-                    <a:p>
-                      <a:pPr algn="ctr"/>
-                      <a:r>
-                        <a:rPr sz="1150" b="0">
-                          <a:solidFill>
-                            <a:srgbClr val="3C3C48"/>
-                          </a:solidFill>
-                          <a:latin typeface="Arial"/>
-                        </a:rPr>
-                        <a:t>0.548</a:t>
-                      </a:r>
-                    </a:p>
-                  </a:txBody>
-                  <a:tcPr anchor="ctr">
-                    <a:solidFill>
-                      <a:srgbClr val="FFFFFF"/>
-                    </a:solidFill>
-                  </a:tcPr>
-                </a:tc>
-              </a:tr>
-              <a:tr h="320040">
-                <a:tc>
-                  <a:txBody>
-                    <a:bodyPr/>
-                    <a:lstStyle/>
-                    <a:p>
-                      <a:pPr algn="ctr"/>
-                      <a:r>
-                        <a:rPr sz="1150" b="0">
-                          <a:solidFill>
-                            <a:srgbClr val="3C3C48"/>
-                          </a:solidFill>
-                          <a:latin typeface="Arial"/>
-                        </a:rPr>
-                        <a:t>20</a:t>
-                      </a:r>
-                    </a:p>
-                  </a:txBody>
-                  <a:tcPr anchor="ctr">
-                    <a:solidFill>
-                      <a:srgbClr val="FFFFFF"/>
-                    </a:solidFill>
-                  </a:tcPr>
-                </a:tc>
-                <a:tc>
-                  <a:txBody>
-                    <a:bodyPr/>
-                    <a:lstStyle/>
-                    <a:p>
-                      <a:pPr algn="ctr"/>
-                      <a:r>
-                        <a:rPr sz="1150" b="0">
-                          <a:solidFill>
-                            <a:srgbClr val="2E5E9E"/>
-                          </a:solidFill>
-                          <a:latin typeface="Arial"/>
-                        </a:rPr>
-                        <a:t>0.705</a:t>
-                      </a:r>
-                    </a:p>
-                  </a:txBody>
-                  <a:tcPr anchor="ctr">
-                    <a:solidFill>
-                      <a:srgbClr val="FFFFFF"/>
-                    </a:solidFill>
-                  </a:tcPr>
-                </a:tc>
-                <a:tc>
-                  <a:txBody>
-                    <a:bodyPr/>
-                    <a:lstStyle/>
-                    <a:p>
-                      <a:pPr algn="ctr"/>
-                      <a:r>
-                        <a:rPr sz="1150" b="0">
-                          <a:solidFill>
-                            <a:srgbClr val="3C3C48"/>
-                          </a:solidFill>
-                          <a:latin typeface="Arial"/>
-                        </a:rPr>
-                        <a:t>0.633</a:t>
-                      </a:r>
-                    </a:p>
-                  </a:txBody>
-                  <a:tcPr anchor="ctr">
-                    <a:solidFill>
-                      <a:srgbClr val="FFFFFF"/>
-                    </a:solidFill>
-                  </a:tcPr>
-                </a:tc>
-                <a:tc>
-                  <a:txBody>
-                    <a:bodyPr/>
-                    <a:lstStyle/>
-                    <a:p>
-                      <a:pPr algn="ctr"/>
-                      <a:r>
-                        <a:rPr sz="1150" b="0">
-                          <a:solidFill>
-                            <a:srgbClr val="3C3C48"/>
-                          </a:solidFill>
-                          <a:latin typeface="Arial"/>
-                        </a:rPr>
-                        <a:t>0.561</a:t>
-                      </a:r>
-                    </a:p>
-                  </a:txBody>
-                  <a:tcPr anchor="ctr">
-                    <a:solidFill>
-                      <a:srgbClr val="FFFFFF"/>
-                    </a:solidFill>
-                  </a:tcPr>
-                </a:tc>
-                <a:tc>
-                  <a:txBody>
-                    <a:bodyPr/>
-                    <a:lstStyle/>
-                    <a:p>
-                      <a:pPr algn="ctr"/>
-                      <a:r>
-                        <a:rPr sz="1150" b="0">
-                          <a:solidFill>
-                            <a:srgbClr val="3C3C48"/>
-                          </a:solidFill>
-                          <a:latin typeface="Arial"/>
-                        </a:rPr>
-                        <a:t>0.580</a:t>
-                      </a:r>
-                    </a:p>
-                  </a:txBody>
-                  <a:tcPr anchor="ctr">
-                    <a:solidFill>
-                      <a:srgbClr val="FFFFFF"/>
-                    </a:solidFill>
-                  </a:tcPr>
-                </a:tc>
-              </a:tr>
-              <a:tr h="320040">
-                <a:tc>
-                  <a:txBody>
-                    <a:bodyPr/>
-                    <a:lstStyle/>
-                    <a:p>
-                      <a:pPr algn="ctr"/>
-                      <a:r>
-                        <a:rPr sz="1150" b="0">
-                          <a:solidFill>
-                            <a:srgbClr val="3C3C48"/>
-                          </a:solidFill>
-                          <a:latin typeface="Arial"/>
-                        </a:rPr>
-                        <a:t>40</a:t>
-                      </a:r>
-                    </a:p>
-                  </a:txBody>
-                  <a:tcPr anchor="ctr">
-                    <a:solidFill>
-                      <a:srgbClr val="FFFFFF"/>
-                    </a:solidFill>
-                  </a:tcPr>
-                </a:tc>
-                <a:tc>
-                  <a:txBody>
-                    <a:bodyPr/>
-                    <a:lstStyle/>
-                    <a:p>
-                      <a:pPr algn="ctr"/>
-                      <a:r>
-                        <a:rPr sz="1150" b="0">
-                          <a:solidFill>
-                            <a:srgbClr val="2E5E9E"/>
-                          </a:solidFill>
-                          <a:latin typeface="Arial"/>
-                        </a:rPr>
-                        <a:t>0.738</a:t>
-                      </a:r>
-                    </a:p>
-                  </a:txBody>
-                  <a:tcPr anchor="ctr">
-                    <a:solidFill>
-                      <a:srgbClr val="FFFFFF"/>
-                    </a:solidFill>
-                  </a:tcPr>
-                </a:tc>
-                <a:tc>
-                  <a:txBody>
-                    <a:bodyPr/>
-                    <a:lstStyle/>
-                    <a:p>
-                      <a:pPr algn="ctr"/>
-                      <a:r>
-                        <a:rPr sz="1150" b="0">
-                          <a:solidFill>
-                            <a:srgbClr val="3C3C48"/>
-                          </a:solidFill>
-                          <a:latin typeface="Arial"/>
-                        </a:rPr>
-                        <a:t>0.672</a:t>
-                      </a:r>
-                    </a:p>
-                  </a:txBody>
-                  <a:tcPr anchor="ctr">
-                    <a:solidFill>
-                      <a:srgbClr val="FFFFFF"/>
-                    </a:solidFill>
-                  </a:tcPr>
-                </a:tc>
-                <a:tc>
-                  <a:txBody>
-                    <a:bodyPr/>
-                    <a:lstStyle/>
-                    <a:p>
-                      <a:pPr algn="ctr"/>
-                      <a:r>
-                        <a:rPr sz="1150" b="0">
-                          <a:solidFill>
-                            <a:srgbClr val="3C3C48"/>
-                          </a:solidFill>
-                          <a:latin typeface="Arial"/>
-                        </a:rPr>
-                        <a:t>0.587</a:t>
-                      </a:r>
-                    </a:p>
-                  </a:txBody>
-                  <a:tcPr anchor="ctr">
-                    <a:solidFill>
-                      <a:srgbClr val="FFFFFF"/>
-                    </a:solidFill>
-                  </a:tcPr>
-                </a:tc>
-                <a:tc>
-                  <a:txBody>
-                    <a:bodyPr/>
-                    <a:lstStyle/>
-                    <a:p>
-                      <a:pPr algn="ctr"/>
-                      <a:r>
-                        <a:rPr sz="1150" b="0">
-                          <a:solidFill>
-                            <a:srgbClr val="3C3C48"/>
-                          </a:solidFill>
-                          <a:latin typeface="Arial"/>
-                        </a:rPr>
-                        <a:t>0.611</a:t>
-                      </a:r>
-                    </a:p>
-                  </a:txBody>
-                  <a:tcPr anchor="ctr">
-                    <a:solidFill>
-                      <a:srgbClr val="FFFFFF"/>
-                    </a:solidFill>
-                  </a:tcPr>
-                </a:tc>
-              </a:tr>
-              <a:tr h="320040">
-                <a:tc>
-                  <a:txBody>
-                    <a:bodyPr/>
-                    <a:lstStyle/>
-                    <a:p>
-                      <a:pPr algn="ctr"/>
-                      <a:r>
-                        <a:rPr sz="1150" b="0">
-                          <a:solidFill>
-                            <a:srgbClr val="3C3C48"/>
-                          </a:solidFill>
-                          <a:latin typeface="Arial"/>
-                        </a:rPr>
-                        <a:t>all</a:t>
-                      </a:r>
-                    </a:p>
-                  </a:txBody>
-                  <a:tcPr anchor="ctr">
-                    <a:solidFill>
-                      <a:srgbClr val="FFFFFF"/>
-                    </a:solidFill>
-                  </a:tcPr>
-                </a:tc>
-                <a:tc>
-                  <a:txBody>
-                    <a:bodyPr/>
-                    <a:lstStyle/>
-                    <a:p>
-                      <a:pPr algn="ctr"/>
-                      <a:r>
-                        <a:rPr sz="1150" b="0">
-                          <a:solidFill>
-                            <a:srgbClr val="2E5E9E"/>
-                          </a:solidFill>
-                          <a:latin typeface="Arial"/>
-                        </a:rPr>
-                        <a:t>0.729</a:t>
-                      </a:r>
-                    </a:p>
-                  </a:txBody>
-                  <a:tcPr anchor="ctr">
-                    <a:solidFill>
-                      <a:srgbClr val="FFFFFF"/>
-                    </a:solidFill>
-                  </a:tcPr>
-                </a:tc>
-                <a:tc>
-                  <a:txBody>
-                    <a:bodyPr/>
-                    <a:lstStyle/>
-                    <a:p>
-                      <a:pPr algn="ctr"/>
-                      <a:r>
-                        <a:rPr sz="1150" b="0">
-                          <a:solidFill>
-                            <a:srgbClr val="3C3C48"/>
-                          </a:solidFill>
-                          <a:latin typeface="Arial"/>
-                        </a:rPr>
-                        <a:t>0.657</a:t>
-                      </a:r>
-                    </a:p>
-                  </a:txBody>
-                  <a:tcPr anchor="ctr">
-                    <a:solidFill>
-                      <a:srgbClr val="FFFFFF"/>
-                    </a:solidFill>
-                  </a:tcPr>
-                </a:tc>
-                <a:tc>
-                  <a:txBody>
-                    <a:bodyPr/>
-                    <a:lstStyle/>
-                    <a:p>
-                      <a:pPr algn="ctr"/>
-                      <a:r>
-                        <a:rPr sz="1150" b="0">
-                          <a:solidFill>
-                            <a:srgbClr val="3C3C48"/>
-                          </a:solidFill>
-                          <a:latin typeface="Arial"/>
-                        </a:rPr>
-                        <a:t>0.573</a:t>
-                      </a:r>
-                    </a:p>
-                  </a:txBody>
-                  <a:tcPr anchor="ctr">
-                    <a:solidFill>
-                      <a:srgbClr val="FFFFFF"/>
-                    </a:solidFill>
-                  </a:tcPr>
-                </a:tc>
-                <a:tc>
-                  <a:txBody>
-                    <a:bodyPr/>
-                    <a:lstStyle/>
-                    <a:p>
-                      <a:pPr algn="ctr"/>
-                      <a:r>
-                        <a:rPr sz="1150" b="0">
-                          <a:solidFill>
-                            <a:srgbClr val="3C3C48"/>
-                          </a:solidFill>
-                          <a:latin typeface="Arial"/>
-                        </a:rPr>
-                        <a:t>0.607</a:t>
-                      </a:r>
-                    </a:p>
-                  </a:txBody>
-                  <a:tcPr anchor="ctr">
-                    <a:solidFill>
-                      <a:srgbClr val="FFFFFF"/>
-                    </a:solidFill>
-                  </a:tcPr>
-                </a:tc>
-              </a:tr>
-            </a:tbl>
-          </a:graphicData>
-        </a:graphic>
-      </p:graphicFrame>
+        </p:nvPicPr>
+        <p:blipFill>
+          <a:blip r:embed="rId2"/>
+          <a:stretch>
+            <a:fillRect/>
+          </a:stretch>
+        </p:blipFill>
+        <p:spPr>
+          <a:xfrm>
+            <a:off x="502920" y="1335024"/>
+            <a:ext cx="11155680" cy="4141124"/>
+          </a:xfrm>
+          <a:prstGeom prst="rect">
+            <a:avLst/>
+          </a:prstGeom>
+        </p:spPr>
+      </p:pic>
       <p:sp>
         <p:nvSpPr>
           <p:cNvPr id="6" name="TextBox 5"/>
@@ -5353,8 +5066,8 @@
         </p:nvSpPr>
         <p:spPr>
           <a:xfrm>
-            <a:off x="502920" y="3474720"/>
-            <a:ext cx="5577840" cy="274320"/>
+            <a:off x="502920" y="5468112"/>
+            <a:ext cx="11155680" cy="274320"/>
           </a:xfrm>
           <a:prstGeom prst="rect">
             <a:avLst/>
@@ -5369,13 +5082,13 @@
           <a:p>
             <a:pPr algn="l"/>
             <a:r>
-              <a:rPr sz="1000" b="0" i="1">
+              <a:rPr sz="950" b="0" i="1">
                 <a:solidFill>
                   <a:srgbClr val="5A5A6E"/>
                 </a:solidFill>
                 <a:latin typeface="Arial"/>
               </a:rPr>
-              <a:t>Mean balanced accuracy, 6 targets x 5 seeds x 50 paired episodes</a:t>
+              <a:t>Balanced accuracy vs labelled examples per class. Error bars: sd across 5 pretraining seeds. Red band: +/- episode sd for classical. 50 paired episodes per point.</a:t>
             </a:r>
           </a:p>
         </p:txBody>
@@ -5388,8 +5101,8 @@
         </p:nvSpPr>
         <p:spPr>
           <a:xfrm>
-            <a:off x="6400800" y="1463040"/>
-            <a:ext cx="5257800" cy="2011680"/>
+            <a:off x="502920" y="5760720"/>
+            <a:ext cx="5486400" cy="969264"/>
           </a:xfrm>
           <a:prstGeom prst="roundRect">
             <a:avLst>
@@ -5397,7 +5110,7 @@
             </a:avLst>
           </a:prstGeom>
           <a:solidFill>
-            <a:srgbClr val="EAF3EC"/>
+            <a:srgbClr val="FBECEC"/>
           </a:solidFill>
           <a:ln>
             <a:noFill/>
@@ -5434,8 +5147,8 @@
         </p:nvSpPr>
         <p:spPr>
           <a:xfrm>
-            <a:off x="6656832" y="1591056"/>
-            <a:ext cx="4754880" cy="292608"/>
+            <a:off x="731520" y="5870448"/>
+            <a:ext cx="5029200" cy="786384"/>
           </a:xfrm>
           <a:prstGeom prst="rect">
             <a:avLst/>
@@ -5450,62 +5163,36 @@
           <a:p>
             <a:pPr algn="l"/>
             <a:r>
-              <a:rPr sz="1500" b="1" i="0">
-                <a:solidFill>
-                  <a:srgbClr val="1F6B3B"/>
+              <a:rPr sz="1050" b="1" i="0">
+                <a:solidFill>
+                  <a:srgbClr val="C0272D"/>
                 </a:solidFill>
                 <a:latin typeface="Arial"/>
               </a:rPr>
-              <a:t>Pretraining does work</a:t>
-            </a:r>
-          </a:p>
-        </p:txBody>
-      </p:sp>
-      <p:sp>
-        <p:nvSpPr>
-          <p:cNvPr id="9" name="TextBox 8"/>
-          <p:cNvSpPr txBox="1"/>
-          <p:nvPr/>
-        </p:nvSpPr>
-        <p:spPr>
-          <a:xfrm>
-            <a:off x="6656832" y="1956816"/>
-            <a:ext cx="4754880" cy="1417320"/>
-          </a:xfrm>
-          <a:prstGeom prst="rect">
-            <a:avLst/>
-          </a:prstGeom>
-          <a:noFill/>
-        </p:spPr>
-        <p:txBody>
-          <a:bodyPr wrap="square" lIns="0" rIns="0" tIns="0" bIns="0">
-            <a:spAutoFit/>
-          </a:bodyPr>
-          <a:lstStyle/>
-          <a:p>
-            <a:pPr algn="l"/>
-            <a:r>
-              <a:rPr sz="1150" b="0" i="0">
+              <a:t>0 SSL wins / 24 classical wins / 5 ties.  </a:t>
+            </a:r>
+            <a:r>
+              <a:rPr sz="1050" b="0" i="0">
                 <a:solidFill>
                   <a:srgbClr val="3C3C48"/>
                 </a:solidFill>
                 <a:latin typeface="Arial"/>
               </a:rPr>
-              <a:t>Against a random-init backbone of identical architecture on identical episodes, masking gains +0.081 to +0.121 balanced accuracy - consistent across all six targets, far above the 0.045 noise floor. The pretext task teaches the encoder something real. It is worth less than what a shrinkage LDA extracts from 500 spectral bins.</a:t>
-            </a:r>
-          </a:p>
-        </p:txBody>
-      </p:sp>
-      <p:sp>
-        <p:nvSpPr>
-          <p:cNvPr id="10" name="Rounded Rectangle 9"/>
+              <a:t>Classical leads in every cohort at every label budget, including k=5, so there is no few-shot crossover. The gap ranges +0.051 to +0.101.</a:t>
+            </a:r>
+          </a:p>
+        </p:txBody>
+      </p:sp>
+      <p:sp>
+        <p:nvSpPr>
+          <p:cNvPr id="9" name="Rounded Rectangle 8"/>
           <p:cNvSpPr/>
           <p:nvPr/>
         </p:nvSpPr>
         <p:spPr>
           <a:xfrm>
-            <a:off x="502920" y="3913632"/>
-            <a:ext cx="11155680" cy="896112"/>
+            <a:off x="6172200" y="5760720"/>
+            <a:ext cx="5486400" cy="969264"/>
           </a:xfrm>
           <a:prstGeom prst="roundRect">
             <a:avLst>
@@ -5513,7 +5200,7 @@
             </a:avLst>
           </a:prstGeom>
           <a:solidFill>
-            <a:srgbClr val="FBECEC"/>
+            <a:srgbClr val="EAF3EC"/>
           </a:solidFill>
           <a:ln>
             <a:noFill/>
@@ -5544,14 +5231,14 @@
       </p:sp>
       <p:sp>
         <p:nvSpPr>
-          <p:cNvPr id="11" name="TextBox 10"/>
+          <p:cNvPr id="10" name="TextBox 9"/>
           <p:cNvSpPr txBox="1"/>
           <p:nvPr/>
         </p:nvSpPr>
         <p:spPr>
           <a:xfrm>
-            <a:off x="777240" y="4041648"/>
-            <a:ext cx="10607040" cy="676656"/>
+            <a:off x="6400800" y="5870448"/>
+            <a:ext cx="5029200" cy="786384"/>
           </a:xfrm>
           <a:prstGeom prst="rect">
             <a:avLst/>
@@ -5566,112 +5253,22 @@
           <a:p>
             <a:pPr algn="l"/>
             <a:r>
-              <a:rPr sz="1150" b="1" i="0">
-                <a:solidFill>
-                  <a:srgbClr val="C0272D"/>
+              <a:rPr sz="1050" b="1" i="0">
+                <a:solidFill>
+                  <a:srgbClr val="1F6B3B"/>
                 </a:solidFill>
                 <a:latin typeface="Arial"/>
               </a:rPr>
-              <a:t>0 SSL wins / 24 classical wins / 5 ties.  </a:t>
-            </a:r>
-            <a:r>
-              <a:rPr sz="1150" b="0" i="0">
+              <a:t>Pretraining does work.  </a:t>
+            </a:r>
+            <a:r>
+              <a:rPr sz="1050" b="0" i="0">
                 <a:solidFill>
                   <a:srgbClr val="3C3C48"/>
                 </a:solidFill>
                 <a:latin typeface="Arial"/>
               </a:rPr>
-              <a:t>Classical leads at every label budget including k=5, so there is no few-shot crossover. Reproducing this on correctly aligned data closes off 'the data was broken' as the explanation.</a:t>
-            </a:r>
-          </a:p>
-        </p:txBody>
-      </p:sp>
-      <p:sp>
-        <p:nvSpPr>
-          <p:cNvPr id="12" name="Rounded Rectangle 11"/>
-          <p:cNvSpPr/>
-          <p:nvPr/>
-        </p:nvSpPr>
-        <p:spPr>
-          <a:xfrm>
-            <a:off x="502920" y="4974336"/>
-            <a:ext cx="11155680" cy="1060704"/>
-          </a:xfrm>
-          <a:prstGeom prst="roundRect">
-            <a:avLst>
-              <a:gd name="adj" fmla="val 4000"/>
-            </a:avLst>
-          </a:prstGeom>
-          <a:solidFill>
-            <a:srgbClr val="F4F2EA"/>
-          </a:solidFill>
-          <a:ln>
-            <a:noFill/>
-          </a:ln>
-          <a:effectLst/>
-        </p:spPr>
-        <p:style>
-          <a:lnRef idx="1">
-            <a:schemeClr val="accent1"/>
-          </a:lnRef>
-          <a:fillRef idx="3">
-            <a:schemeClr val="accent1"/>
-          </a:fillRef>
-          <a:effectRef idx="2">
-            <a:schemeClr val="accent1"/>
-          </a:effectRef>
-          <a:fontRef idx="minor">
-            <a:schemeClr val="lt1"/>
-          </a:fontRef>
-        </p:style>
-        <p:txBody>
-          <a:bodyPr rtlCol="0" anchor="ctr"/>
-          <a:lstStyle/>
-          <a:p>
-            <a:pPr algn="ctr"/>
-          </a:p>
-        </p:txBody>
-      </p:sp>
-      <p:sp>
-        <p:nvSpPr>
-          <p:cNvPr id="13" name="TextBox 12"/>
-          <p:cNvSpPr txBox="1"/>
-          <p:nvPr/>
-        </p:nvSpPr>
-        <p:spPr>
-          <a:xfrm>
-            <a:off x="777240" y="5102352"/>
-            <a:ext cx="10607040" cy="859536"/>
-          </a:xfrm>
-          <a:prstGeom prst="rect">
-            <a:avLst/>
-          </a:prstGeom>
-          <a:noFill/>
-        </p:spPr>
-        <p:txBody>
-          <a:bodyPr wrap="square" lIns="0" rIns="0" tIns="0" bIns="0">
-            <a:spAutoFit/>
-          </a:bodyPr>
-          <a:lstStyle/>
-          <a:p>
-            <a:pPr algn="l"/>
-            <a:r>
-              <a:rPr sz="1100" b="1" i="0">
-                <a:solidFill>
-                  <a:srgbClr val="3C3C48"/>
-                </a:solidFill>
-                <a:latin typeface="Arial"/>
-              </a:rPr>
-              <a:t>Two claims withdrawn this week.  </a:t>
-            </a:r>
-            <a:r>
-              <a:rPr sz="1100" b="0" i="0">
-                <a:solidFill>
-                  <a:srgbClr val="3C3C48"/>
-                </a:solidFill>
-                <a:latin typeface="Arial"/>
-              </a:rPr>
-              <a:t>(1) Effective rank does not predict transfer - I predicted joint would win on that basis, and masking won at every budget. (2) An apparent Barth win was selection bias from reporting the best of 15 checkpoints; every objective's seed mean is below classical. That same error was retracted once before, so the summary now reports seed means and marks best-of-15 as an upper bound.</a:t>
+              <a:t>Masking beats a random-init backbone by +0.081 to +0.121 on identical episodes - far above the 0.045 noise floor. Still less than a shrinkage LDA on 500 bins.</a:t>
             </a:r>
           </a:p>
         </p:txBody>
@@ -6221,7 +5818,8 @@
                           </a:solidFill>
                           <a:latin typeface="Arial"/>
                         </a:rPr>
-                        <a:t>k=10</a:t>
+                        <a:t>10 labels
+/class</a:t>
                       </a:r>
                     </a:p>
                   </a:txBody>
@@ -6244,7 +5842,8 @@
                           </a:solidFill>
                           <a:latin typeface="Arial"/>
                         </a:rPr>
-                        <a:t>k=all</a:t>
+                        <a:t>all
+labels</a:t>
                       </a:r>
                     </a:p>
                   </a:txBody>
@@ -6764,8 +6363,8 @@
         </p:nvSpPr>
         <p:spPr>
           <a:xfrm>
-            <a:off x="502920" y="4041648"/>
-            <a:ext cx="5486400" cy="274320"/>
+            <a:off x="502920" y="3986784"/>
+            <a:ext cx="5669280" cy="274320"/>
           </a:xfrm>
           <a:prstGeom prst="rect">
             <a:avLst/>
@@ -6780,13 +6379,13 @@
           <a:p>
             <a:pPr algn="l"/>
             <a:r>
-              <a:rPr sz="1000" b="0" i="1">
+              <a:rPr sz="950" b="0" i="1">
                 <a:solidFill>
                   <a:srgbClr val="5A5A6E"/>
                 </a:solidFill>
                 <a:latin typeface="Arial"/>
               </a:rPr>
-              <a:t>Masking, mean over 6 targets; seed sd 0.002-0.021</a:t>
+              <a:t>Masking, mean over 6 targets; seed sd 0.002-0.021. Columns = label budget.</a:t>
             </a:r>
           </a:p>
         </p:txBody>
@@ -7619,4 +7218,324 @@
   </a:objectDefaults>
   <a:extraClrSchemeLst/>
 </a:theme>
+</file>
+
+<file path=ppt/theme/theme2.xml><?xml version="1.0" encoding="utf-8"?>
+<a:theme xmlns:a="http://schemas.openxmlformats.org/drawingml/2006/main" name="Office Theme">
+  <a:themeElements>
+    <a:clrScheme name="Office">
+      <a:dk1>
+        <a:sysClr val="windowText" lastClr="000000"/>
+      </a:dk1>
+      <a:lt1>
+        <a:sysClr val="window" lastClr="FFFFFF"/>
+      </a:lt1>
+      <a:dk2>
+        <a:srgbClr val="1F497D"/>
+      </a:dk2>
+      <a:lt2>
+        <a:srgbClr val="EEECE1"/>
+      </a:lt2>
+      <a:accent1>
+        <a:srgbClr val="4F81BD"/>
+      </a:accent1>
+      <a:accent2>
+        <a:srgbClr val="C0504D"/>
+      </a:accent2>
+      <a:accent3>
+        <a:srgbClr val="9BBB59"/>
+      </a:accent3>
+      <a:accent4>
+        <a:srgbClr val="8064A2"/>
+      </a:accent4>
+      <a:accent5>
+        <a:srgbClr val="4BACC6"/>
+      </a:accent5>
+      <a:accent6>
+        <a:srgbClr val="F79646"/>
+      </a:accent6>
+      <a:hlink>
+        <a:srgbClr val="0000FF"/>
+      </a:hlink>
+      <a:folHlink>
+        <a:srgbClr val="800080"/>
+      </a:folHlink>
+    </a:clrScheme>
+    <a:fontScheme name="Office">
+      <a:majorFont>
+        <a:latin typeface="Calibri"/>
+        <a:ea typeface=""/>
+        <a:cs typeface=""/>
+        <a:font script="Jpan" typeface="ＭＳ Ｐゴシック"/>
+        <a:font script="Hang" typeface="맑은 고딕"/>
+        <a:font script="Hans" typeface="宋体"/>
+        <a:font script="Hant" typeface="新細明體"/>
+        <a:font script="Arab" typeface="Times New Roman"/>
+        <a:font script="Hebr" typeface="Times New Roman"/>
+        <a:font script="Thai" typeface="Angsana New"/>
+        <a:font script="Ethi" typeface="Nyala"/>
+        <a:font script="Beng" typeface="Vrinda"/>
+        <a:font script="Gujr" typeface="Shruti"/>
+        <a:font script="Khmr" typeface="MoolBoran"/>
+        <a:font script="Knda" typeface="Tunga"/>
+        <a:font script="Guru" typeface="Raavi"/>
+        <a:font script="Cans" typeface="Euphemia"/>
+        <a:font script="Cher" typeface="Plantagenet Cherokee"/>
+        <a:font script="Yiii" typeface="Microsoft Yi Baiti"/>
+        <a:font script="Tibt" typeface="Microsoft Himalaya"/>
+        <a:font script="Thaa" typeface="MV Boli"/>
+        <a:font script="Deva" typeface="Mangal"/>
+        <a:font script="Telu" typeface="Gautami"/>
+        <a:font script="Taml" typeface="Latha"/>
+        <a:font script="Syrc" typeface="Estrangelo Edessa"/>
+        <a:font script="Orya" typeface="Kalinga"/>
+        <a:font script="Mlym" typeface="Kartika"/>
+        <a:font script="Laoo" typeface="DokChampa"/>
+        <a:font script="Sinh" typeface="Iskoola Pota"/>
+        <a:font script="Mong" typeface="Mongolian Baiti"/>
+        <a:font script="Viet" typeface="Times New Roman"/>
+        <a:font script="Uigh" typeface="Microsoft Uighur"/>
+        <a:font script="Geor" typeface="Sylfaen"/>
+      </a:majorFont>
+      <a:minorFont>
+        <a:latin typeface="Calibri"/>
+        <a:ea typeface=""/>
+        <a:cs typeface=""/>
+        <a:font script="Jpan" typeface="ＭＳ Ｐゴシック"/>
+        <a:font script="Hang" typeface="맑은 고딕"/>
+        <a:font script="Hans" typeface="宋体"/>
+        <a:font script="Hant" typeface="新細明體"/>
+        <a:font script="Arab" typeface="Arial"/>
+        <a:font script="Hebr" typeface="Arial"/>
+        <a:font script="Thai" typeface="Cordia New"/>
+        <a:font script="Ethi" typeface="Nyala"/>
+        <a:font script="Beng" typeface="Vrinda"/>
+        <a:font script="Gujr" typeface="Shruti"/>
+        <a:font script="Khmr" typeface="DaunPenh"/>
+        <a:font script="Knda" typeface="Tunga"/>
+        <a:font script="Guru" typeface="Raavi"/>
+        <a:font script="Cans" typeface="Euphemia"/>
+        <a:font script="Cher" typeface="Plantagenet Cherokee"/>
+        <a:font script="Yiii" typeface="Microsoft Yi Baiti"/>
+        <a:font script="Tibt" typeface="Microsoft Himalaya"/>
+        <a:font script="Thaa" typeface="MV Boli"/>
+        <a:font script="Deva" typeface="Mangal"/>
+        <a:font script="Telu" typeface="Gautami"/>
+        <a:font script="Taml" typeface="Latha"/>
+        <a:font script="Syrc" typeface="Estrangelo Edessa"/>
+        <a:font script="Orya" typeface="Kalinga"/>
+        <a:font script="Mlym" typeface="Kartika"/>
+        <a:font script="Laoo" typeface="DokChampa"/>
+        <a:font script="Sinh" typeface="Iskoola Pota"/>
+        <a:font script="Mong" typeface="Mongolian Baiti"/>
+        <a:font script="Viet" typeface="Arial"/>
+        <a:font script="Uigh" typeface="Microsoft Uighur"/>
+        <a:font script="Geor" typeface="Sylfaen"/>
+      </a:minorFont>
+    </a:fontScheme>
+    <a:fmtScheme name="Office">
+      <a:fillStyleLst>
+        <a:solidFill>
+          <a:schemeClr val="phClr"/>
+        </a:solidFill>
+        <a:gradFill rotWithShape="1">
+          <a:gsLst>
+            <a:gs pos="0">
+              <a:schemeClr val="phClr">
+                <a:tint val="50000"/>
+                <a:satMod val="300000"/>
+              </a:schemeClr>
+            </a:gs>
+            <a:gs pos="35000">
+              <a:schemeClr val="phClr">
+                <a:tint val="37000"/>
+                <a:satMod val="300000"/>
+              </a:schemeClr>
+            </a:gs>
+            <a:gs pos="100000">
+              <a:schemeClr val="phClr">
+                <a:tint val="15000"/>
+                <a:satMod val="350000"/>
+              </a:schemeClr>
+            </a:gs>
+          </a:gsLst>
+          <a:lin ang="16200000" scaled="1"/>
+        </a:gradFill>
+        <a:gradFill rotWithShape="1">
+          <a:gsLst>
+            <a:gs pos="0">
+              <a:schemeClr val="phClr">
+                <a:tint val="100000"/>
+                <a:shade val="100000"/>
+                <a:satMod val="130000"/>
+              </a:schemeClr>
+            </a:gs>
+            <a:gs pos="100000">
+              <a:schemeClr val="phClr">
+                <a:tint val="50000"/>
+                <a:shade val="100000"/>
+                <a:satMod val="350000"/>
+              </a:schemeClr>
+            </a:gs>
+          </a:gsLst>
+          <a:lin ang="16200000" scaled="0"/>
+        </a:gradFill>
+      </a:fillStyleLst>
+      <a:lnStyleLst>
+        <a:ln w="9525" cap="flat" cmpd="sng" algn="ctr">
+          <a:solidFill>
+            <a:schemeClr val="phClr">
+              <a:shade val="95000"/>
+              <a:satMod val="105000"/>
+            </a:schemeClr>
+          </a:solidFill>
+          <a:prstDash val="solid"/>
+        </a:ln>
+        <a:ln w="25400" cap="flat" cmpd="sng" algn="ctr">
+          <a:solidFill>
+            <a:schemeClr val="phClr"/>
+          </a:solidFill>
+          <a:prstDash val="solid"/>
+        </a:ln>
+        <a:ln w="38100" cap="flat" cmpd="sng" algn="ctr">
+          <a:solidFill>
+            <a:schemeClr val="phClr"/>
+          </a:solidFill>
+          <a:prstDash val="solid"/>
+        </a:ln>
+      </a:lnStyleLst>
+      <a:effectStyleLst>
+        <a:effectStyle>
+          <a:effectLst>
+            <a:outerShdw blurRad="40000" dist="20000" dir="5400000" rotWithShape="0">
+              <a:srgbClr val="000000">
+                <a:alpha val="38000"/>
+              </a:srgbClr>
+            </a:outerShdw>
+          </a:effectLst>
+        </a:effectStyle>
+        <a:effectStyle>
+          <a:effectLst>
+            <a:outerShdw blurRad="40000" dist="23000" dir="5400000" rotWithShape="0">
+              <a:srgbClr val="000000">
+                <a:alpha val="35000"/>
+              </a:srgbClr>
+            </a:outerShdw>
+          </a:effectLst>
+        </a:effectStyle>
+        <a:effectStyle>
+          <a:effectLst>
+            <a:outerShdw blurRad="40000" dist="23000" dir="5400000" rotWithShape="0">
+              <a:srgbClr val="000000">
+                <a:alpha val="35000"/>
+              </a:srgbClr>
+            </a:outerShdw>
+          </a:effectLst>
+          <a:scene3d>
+            <a:camera prst="orthographicFront">
+              <a:rot lat="0" lon="0" rev="0"/>
+            </a:camera>
+            <a:lightRig rig="threePt" dir="t">
+              <a:rot lat="0" lon="0" rev="1200000"/>
+            </a:lightRig>
+          </a:scene3d>
+          <a:sp3d>
+            <a:bevelT w="63500" h="25400"/>
+          </a:sp3d>
+        </a:effectStyle>
+      </a:effectStyleLst>
+      <a:bgFillStyleLst>
+        <a:solidFill>
+          <a:schemeClr val="phClr"/>
+        </a:solidFill>
+        <a:gradFill rotWithShape="1">
+          <a:gsLst>
+            <a:gs pos="0">
+              <a:schemeClr val="phClr">
+                <a:tint val="40000"/>
+                <a:satMod val="350000"/>
+              </a:schemeClr>
+            </a:gs>
+            <a:gs pos="40000">
+              <a:schemeClr val="phClr">
+                <a:tint val="45000"/>
+                <a:shade val="99000"/>
+                <a:satMod val="350000"/>
+              </a:schemeClr>
+            </a:gs>
+            <a:gs pos="100000">
+              <a:schemeClr val="phClr">
+                <a:shade val="20000"/>
+                <a:satMod val="255000"/>
+              </a:schemeClr>
+            </a:gs>
+          </a:gsLst>
+          <a:path path="circle">
+            <a:fillToRect l="50000" t="-80000" r="50000" b="180000"/>
+          </a:path>
+        </a:gradFill>
+        <a:gradFill rotWithShape="1">
+          <a:gsLst>
+            <a:gs pos="0">
+              <a:schemeClr val="phClr">
+                <a:tint val="80000"/>
+                <a:satMod val="300000"/>
+              </a:schemeClr>
+            </a:gs>
+            <a:gs pos="100000">
+              <a:schemeClr val="phClr">
+                <a:shade val="30000"/>
+                <a:satMod val="200000"/>
+              </a:schemeClr>
+            </a:gs>
+          </a:gsLst>
+          <a:path path="circle">
+            <a:fillToRect l="50000" t="50000" r="50000" b="50000"/>
+          </a:path>
+        </a:gradFill>
+      </a:bgFillStyleLst>
+    </a:fmtScheme>
+  </a:themeElements>
+  <a:objectDefaults>
+    <a:spDef>
+      <a:spPr/>
+      <a:bodyPr/>
+      <a:lstStyle/>
+      <a:style>
+        <a:lnRef idx="1">
+          <a:schemeClr val="accent1"/>
+        </a:lnRef>
+        <a:fillRef idx="3">
+          <a:schemeClr val="accent1"/>
+        </a:fillRef>
+        <a:effectRef idx="2">
+          <a:schemeClr val="accent1"/>
+        </a:effectRef>
+        <a:fontRef idx="minor">
+          <a:schemeClr val="lt1"/>
+        </a:fontRef>
+      </a:style>
+    </a:spDef>
+    <a:lnDef>
+      <a:spPr/>
+      <a:bodyPr/>
+      <a:lstStyle/>
+      <a:style>
+        <a:lnRef idx="2">
+          <a:schemeClr val="accent1"/>
+        </a:lnRef>
+        <a:fillRef idx="0">
+          <a:schemeClr val="accent1"/>
+        </a:fillRef>
+        <a:effectRef idx="1">
+          <a:schemeClr val="accent1"/>
+        </a:effectRef>
+        <a:fontRef idx="minor">
+          <a:schemeClr val="tx1"/>
+        </a:fontRef>
+      </a:style>
+    </a:lnDef>
+  </a:objectDefaults>
+  <a:extraClrSchemeLst/>
+</a:theme>
 </file>
</xml_diff>